<commit_message>
Simplify Android merge labels in Sprint 5 presentation
</commit_message>
<xml_diff>
--- a/Sprints/Sprint_5/PPT/Sprint5_Review.pptx
+++ b/Sprints/Sprint_5/PPT/Sprint5_Review.pptx
@@ -12276,7 +12276,7 @@
                 </a:solidFill>
                 <a:latin typeface="Arial"/>
               </a:rPr>
-              <a:t>MERGED IN #38</a:t>
+              <a:t>MERGED</a:t>
             </a:r>
           </a:p>
         </p:txBody>
@@ -15691,7 +15691,7 @@
                 </a:solidFill>
                 <a:latin typeface="Arial"/>
               </a:rPr>
-              <a:t>#32 CLOSED · MERGED INTO MAIN IN #38</a:t>
+              <a:t>MERGED</a:t>
             </a:r>
           </a:p>
         </p:txBody>

</xml_diff>